<commit_message>
docs(submission): finalize judge deck and video narrative
</commit_message>
<xml_diff>
--- a/docs/submission/aeos-buidl-ctc-2026-fall.pptx
+++ b/docs/submission/aeos-buidl-ctc-2026-fall.pptx
@@ -2,22 +2,22 @@
 <file path=ppt/presentation.xml><?xml version="1.0" encoding="utf-8"?>
 <p:presentation xmlns:p="http://schemas.openxmlformats.org/presentationml/2006/main">
   <p:sldMasterIdLst>
-    <p:sldMasterId xmlns:r="http://schemas.openxmlformats.org/officeDocument/2006/relationships" id="2147483648" r:id="Rd92b57b082df41be"/>
+    <p:sldMasterId xmlns:r="http://schemas.openxmlformats.org/officeDocument/2006/relationships" id="2147483648" r:id="Rc19dec4bbc504d79"/>
   </p:sldMasterIdLst>
   <p:notesMasterIdLst>
-    <p:notesMasterId xmlns:r="http://schemas.openxmlformats.org/officeDocument/2006/relationships" r:id="Rfa11fee45f374cd6"/>
+    <p:notesMasterId xmlns:r="http://schemas.openxmlformats.org/officeDocument/2006/relationships" r:id="R26438aa8a3f64160"/>
   </p:notesMasterIdLst>
   <p:sldIdLst>
-    <p:sldId xmlns:r="http://schemas.openxmlformats.org/officeDocument/2006/relationships" id="256" r:id="R3b0cec034994441d"/>
-    <p:sldId xmlns:r="http://schemas.openxmlformats.org/officeDocument/2006/relationships" id="257" r:id="Re7646e9e2e5a4986"/>
-    <p:sldId xmlns:r="http://schemas.openxmlformats.org/officeDocument/2006/relationships" id="258" r:id="Rbb61561e95b8447c"/>
-    <p:sldId xmlns:r="http://schemas.openxmlformats.org/officeDocument/2006/relationships" id="259" r:id="Rcd708c96d60641e4"/>
-    <p:sldId xmlns:r="http://schemas.openxmlformats.org/officeDocument/2006/relationships" id="260" r:id="Rd39be79073aa4684"/>
-    <p:sldId xmlns:r="http://schemas.openxmlformats.org/officeDocument/2006/relationships" id="261" r:id="R9e69059f91db4d1b"/>
-    <p:sldId xmlns:r="http://schemas.openxmlformats.org/officeDocument/2006/relationships" id="262" r:id="R43de5405527e47d5"/>
-    <p:sldId xmlns:r="http://schemas.openxmlformats.org/officeDocument/2006/relationships" id="263" r:id="R5f97d80f83974d2a"/>
-    <p:sldId xmlns:r="http://schemas.openxmlformats.org/officeDocument/2006/relationships" id="264" r:id="Rac4b15b096cf499a"/>
-    <p:sldId xmlns:r="http://schemas.openxmlformats.org/officeDocument/2006/relationships" id="265" r:id="Re920d768e565457d"/>
+    <p:sldId xmlns:r="http://schemas.openxmlformats.org/officeDocument/2006/relationships" id="256" r:id="Rd796ebe19e55411b"/>
+    <p:sldId xmlns:r="http://schemas.openxmlformats.org/officeDocument/2006/relationships" id="257" r:id="R9f84659d37ca429b"/>
+    <p:sldId xmlns:r="http://schemas.openxmlformats.org/officeDocument/2006/relationships" id="258" r:id="Rd08db438595e427f"/>
+    <p:sldId xmlns:r="http://schemas.openxmlformats.org/officeDocument/2006/relationships" id="259" r:id="R005eee4721804791"/>
+    <p:sldId xmlns:r="http://schemas.openxmlformats.org/officeDocument/2006/relationships" id="260" r:id="R9ea8b250027f49ed"/>
+    <p:sldId xmlns:r="http://schemas.openxmlformats.org/officeDocument/2006/relationships" id="261" r:id="Rb7ecf6dc55ea4d17"/>
+    <p:sldId xmlns:r="http://schemas.openxmlformats.org/officeDocument/2006/relationships" id="262" r:id="R234eec48bd6e4f5d"/>
+    <p:sldId xmlns:r="http://schemas.openxmlformats.org/officeDocument/2006/relationships" id="263" r:id="R142c6ec6c15d4bc2"/>
+    <p:sldId xmlns:r="http://schemas.openxmlformats.org/officeDocument/2006/relationships" id="264" r:id="Ra5ad1c53ad0c46c2"/>
+    <p:sldId xmlns:r="http://schemas.openxmlformats.org/officeDocument/2006/relationships" id="265" r:id="R258f05294cda4835"/>
   </p:sldIdLst>
   <p:sldSz cx="12192000" cy="6858000"/>
   <p:notesSz cx="6858000" cy="9144000"/>
@@ -1449,7 +1449,7 @@
   </p:cSld>
   <p:clrMap bg1="lt1" tx1="dk1" bg2="lt2" tx2="dk2" accent1="accent1" accent2="accent2" accent3="accent3" accent4="accent4" accent5="accent5" accent6="accent6" hlink="hlink" folHlink="folHlink"/>
   <p:sldLayoutIdLst>
-    <p:sldLayoutId xmlns:r="http://schemas.openxmlformats.org/officeDocument/2006/relationships" id="2147483649" r:id="R7ca20950582a4246"/>
+    <p:sldLayoutId xmlns:r="http://schemas.openxmlformats.org/officeDocument/2006/relationships" id="2147483649" r:id="R07a904232df6482e"/>
   </p:sldLayoutIdLst>
   <p:txStyles>
     <p:titleStyle>
@@ -2059,6 +2059,7 @@
           <a:lstStyle xmlns:a="http://schemas.openxmlformats.org/drawingml/2006/main"/>
           <a:p xmlns:a="http://schemas.openxmlformats.org/drawingml/2006/main">
             <a:pPr>
+              <a:buNone/>
               <a:defRPr sz="4800" b="1">
                 <a:solidFill>
                   <a:srgbClr val="F2FBFF"/>
@@ -2109,6 +2110,7 @@
           <a:lstStyle xmlns:a="http://schemas.openxmlformats.org/drawingml/2006/main"/>
           <a:p xmlns:a="http://schemas.openxmlformats.org/drawingml/2006/main">
             <a:pPr>
+              <a:buNone/>
               <a:defRPr sz="1200" b="1">
                 <a:solidFill>
                   <a:srgbClr val="13E6FF"/>
@@ -2159,6 +2161,7 @@
           <a:lstStyle xmlns:a="http://schemas.openxmlformats.org/drawingml/2006/main"/>
           <a:p xmlns:a="http://schemas.openxmlformats.org/drawingml/2006/main">
             <a:pPr>
+              <a:buNone/>
               <a:defRPr sz="3150" b="1">
                 <a:solidFill>
                   <a:srgbClr val="F2FBFF"/>
@@ -2176,6 +2179,7 @@
           </a:p>
           <a:p xmlns:a="http://schemas.openxmlformats.org/drawingml/2006/main">
             <a:pPr>
+              <a:buNone/>
               <a:defRPr sz="3150" b="1">
                 <a:solidFill>
                   <a:srgbClr val="F2FBFF"/>
@@ -2193,6 +2197,7 @@
           </a:p>
           <a:p xmlns:a="http://schemas.openxmlformats.org/drawingml/2006/main">
             <a:pPr>
+              <a:buNone/>
               <a:defRPr sz="3150" b="1">
                 <a:solidFill>
                   <a:srgbClr val="F2FBFF"/>
@@ -2274,6 +2279,7 @@
           <a:lstStyle xmlns:a="http://schemas.openxmlformats.org/drawingml/2006/main"/>
           <a:p xmlns:a="http://schemas.openxmlformats.org/drawingml/2006/main">
             <a:pPr>
+              <a:buNone/>
               <a:defRPr sz="1350" b="1">
                 <a:solidFill>
                   <a:srgbClr val="FFBE3D"/>
@@ -2324,6 +2330,7 @@
           <a:lstStyle xmlns:a="http://schemas.openxmlformats.org/drawingml/2006/main"/>
           <a:p xmlns:a="http://schemas.openxmlformats.org/drawingml/2006/main">
             <a:pPr>
+              <a:buNone/>
               <a:defRPr sz="1650" b="0">
                 <a:solidFill>
                   <a:srgbClr val="8EB2C5"/>
@@ -2409,6 +2416,7 @@
           <a:lstStyle xmlns:a="http://schemas.openxmlformats.org/drawingml/2006/main"/>
           <a:p xmlns:a="http://schemas.openxmlformats.org/drawingml/2006/main">
             <a:pPr>
+              <a:buNone/>
               <a:defRPr sz="1050" b="1">
                 <a:solidFill>
                   <a:srgbClr val="58F28B"/>
@@ -2519,6 +2527,7 @@
           <a:lstStyle xmlns:a="http://schemas.openxmlformats.org/drawingml/2006/main"/>
           <a:p xmlns:a="http://schemas.openxmlformats.org/drawingml/2006/main">
             <a:pPr>
+              <a:buNone/>
               <a:defRPr sz="1125" b="1">
                 <a:solidFill>
                   <a:srgbClr val="13E6FF"/>
@@ -2531,7 +2540,7 @@
                   <a:srgbClr val="13E6FF"/>
                 </a:solidFill>
               </a:rPr>
-              <a:t>WHY AEOS</a:t>
+              <a:t>WHY AEOS / CEIP PATH</a:t>
             </a:r>
           </a:p>
         </p:txBody>
@@ -2569,6 +2578,7 @@
           <a:lstStyle xmlns:a="http://schemas.openxmlformats.org/drawingml/2006/main"/>
           <a:p xmlns:a="http://schemas.openxmlformats.org/drawingml/2006/main">
             <a:pPr>
+              <a:buNone/>
               <a:defRPr sz="1125" b="1">
                 <a:solidFill>
                   <a:srgbClr val="8EB2C5"/>
@@ -2619,6 +2629,7 @@
           <a:lstStyle xmlns:a="http://schemas.openxmlformats.org/drawingml/2006/main"/>
           <a:p xmlns:a="http://schemas.openxmlformats.org/drawingml/2006/main">
             <a:pPr>
+              <a:buNone/>
               <a:defRPr sz="2850" b="1">
                 <a:solidFill>
                   <a:srgbClr val="F2FBFF"/>
@@ -2631,7 +2642,7 @@
                   <a:srgbClr val="F2FBFF"/>
                 </a:solidFill>
               </a:rPr>
-              <a:t>Verifiable evidence makes AI governance safe enough to be useful</a:t>
+              <a:t>Auditable AI governance for multi-chain treasuries</a:t>
             </a:r>
           </a:p>
         </p:txBody>
@@ -2700,6 +2711,7 @@
           <a:lstStyle xmlns:a="http://schemas.openxmlformats.org/drawingml/2006/main"/>
           <a:p xmlns:a="http://schemas.openxmlformats.org/drawingml/2006/main">
             <a:pPr>
+              <a:buNone/>
               <a:defRPr sz="900" b="1">
                 <a:solidFill>
                   <a:srgbClr val="8EB2C5"/>
@@ -2750,6 +2762,7 @@
           <a:lstStyle xmlns:a="http://schemas.openxmlformats.org/drawingml/2006/main"/>
           <a:p xmlns:a="http://schemas.openxmlformats.org/drawingml/2006/main">
             <a:pPr>
+              <a:buNone/>
               <a:defRPr sz="2250" b="1">
                 <a:solidFill>
                   <a:srgbClr val="13E6FF"/>
@@ -2800,6 +2813,7 @@
           <a:lstStyle xmlns:a="http://schemas.openxmlformats.org/drawingml/2006/main"/>
           <a:p xmlns:a="http://schemas.openxmlformats.org/drawingml/2006/main">
             <a:pPr>
+              <a:buNone/>
               <a:defRPr sz="1500" b="0">
                 <a:solidFill>
                   <a:srgbClr val="8EB2C5"/>
@@ -2850,6 +2864,7 @@
           <a:lstStyle xmlns:a="http://schemas.openxmlformats.org/drawingml/2006/main"/>
           <a:p xmlns:a="http://schemas.openxmlformats.org/drawingml/2006/main">
             <a:pPr>
+              <a:buNone/>
               <a:defRPr sz="2250" b="1">
                 <a:solidFill>
                   <a:srgbClr val="A875FF"/>
@@ -2900,6 +2915,7 @@
           <a:lstStyle xmlns:a="http://schemas.openxmlformats.org/drawingml/2006/main"/>
           <a:p xmlns:a="http://schemas.openxmlformats.org/drawingml/2006/main">
             <a:pPr>
+              <a:buNone/>
               <a:defRPr sz="1500" b="0">
                 <a:solidFill>
                   <a:srgbClr val="8EB2C5"/>
@@ -2950,6 +2966,7 @@
           <a:lstStyle xmlns:a="http://schemas.openxmlformats.org/drawingml/2006/main"/>
           <a:p xmlns:a="http://schemas.openxmlformats.org/drawingml/2006/main">
             <a:pPr>
+              <a:buNone/>
               <a:defRPr sz="2250" b="1">
                 <a:solidFill>
                   <a:srgbClr val="FFBE3D"/>
@@ -3000,6 +3017,7 @@
           <a:lstStyle xmlns:a="http://schemas.openxmlformats.org/drawingml/2006/main"/>
           <a:p xmlns:a="http://schemas.openxmlformats.org/drawingml/2006/main">
             <a:pPr>
+              <a:buNone/>
               <a:defRPr sz="1500" b="0">
                 <a:solidFill>
                   <a:srgbClr val="8EB2C5"/>
@@ -3081,6 +3099,7 @@
           <a:lstStyle xmlns:a="http://schemas.openxmlformats.org/drawingml/2006/main"/>
           <a:p xmlns:a="http://schemas.openxmlformats.org/drawingml/2006/main">
             <a:pPr>
+              <a:buNone/>
               <a:defRPr sz="2400" b="1">
                 <a:solidFill>
                   <a:srgbClr val="F2FBFF"/>
@@ -3093,7 +3112,7 @@
                   <a:srgbClr val="F2FBFF"/>
                 </a:solidFill>
               </a:rPr>
-              <a:t>AEOS is the evidence-first operating system for decentralized investment organizations.</a:t>
+              <a:t>AEOS turns verified cross-chain facts into cited institutional advice and governed outcomes—without giving AI asset authority.</a:t>
             </a:r>
           </a:p>
         </p:txBody>
@@ -3131,6 +3150,7 @@
           <a:lstStyle xmlns:a="http://schemas.openxmlformats.org/drawingml/2006/main"/>
           <a:p xmlns:a="http://schemas.openxmlformats.org/drawingml/2006/main">
             <a:pPr>
+              <a:buNone/>
               <a:defRPr sz="1350" b="1">
                 <a:solidFill>
                   <a:srgbClr val="8EB2C5"/>
@@ -3216,6 +3236,7 @@
           <a:lstStyle xmlns:a="http://schemas.openxmlformats.org/drawingml/2006/main"/>
           <a:p xmlns:a="http://schemas.openxmlformats.org/drawingml/2006/main">
             <a:pPr>
+              <a:buNone/>
               <a:defRPr sz="1050" b="1">
                 <a:solidFill>
                   <a:srgbClr val="58F28B"/>
@@ -3228,7 +3249,7 @@
                   <a:srgbClr val="58F28B"/>
                 </a:solidFill>
               </a:rPr>
-              <a:t>AI ASSISTED · HUMAN ACCOUNTABLE</a:t>
+              <a:t>AUDIT-READY · HUMAN ACCOUNTABLE</a:t>
             </a:r>
           </a:p>
         </p:txBody>
@@ -3326,6 +3347,7 @@
           <a:lstStyle xmlns:a="http://schemas.openxmlformats.org/drawingml/2006/main"/>
           <a:p xmlns:a="http://schemas.openxmlformats.org/drawingml/2006/main">
             <a:pPr>
+              <a:buNone/>
               <a:defRPr sz="1125" b="1">
                 <a:solidFill>
                   <a:srgbClr val="13E6FF"/>
@@ -3376,6 +3398,7 @@
           <a:lstStyle xmlns:a="http://schemas.openxmlformats.org/drawingml/2006/main"/>
           <a:p xmlns:a="http://schemas.openxmlformats.org/drawingml/2006/main">
             <a:pPr>
+              <a:buNone/>
               <a:defRPr sz="1125" b="1">
                 <a:solidFill>
                   <a:srgbClr val="8EB2C5"/>
@@ -3426,6 +3449,7 @@
           <a:lstStyle xmlns:a="http://schemas.openxmlformats.org/drawingml/2006/main"/>
           <a:p xmlns:a="http://schemas.openxmlformats.org/drawingml/2006/main">
             <a:pPr>
+              <a:buNone/>
               <a:defRPr sz="2850" b="1">
                 <a:solidFill>
                   <a:srgbClr val="F2FBFF"/>
@@ -3476,6 +3500,7 @@
           <a:lstStyle xmlns:a="http://schemas.openxmlformats.org/drawingml/2006/main"/>
           <a:p xmlns:a="http://schemas.openxmlformats.org/drawingml/2006/main">
             <a:pPr>
+              <a:buNone/>
               <a:defRPr sz="1500" b="0">
                 <a:solidFill>
                   <a:srgbClr val="8EB2C5"/>
@@ -3557,6 +3582,7 @@
           <a:lstStyle xmlns:a="http://schemas.openxmlformats.org/drawingml/2006/main"/>
           <a:p xmlns:a="http://schemas.openxmlformats.org/drawingml/2006/main">
             <a:pPr>
+              <a:buNone/>
               <a:defRPr sz="900" b="1">
                 <a:solidFill>
                   <a:srgbClr val="8EB2C5"/>
@@ -3607,6 +3633,7 @@
           <a:lstStyle xmlns:a="http://schemas.openxmlformats.org/drawingml/2006/main"/>
           <a:p xmlns:a="http://schemas.openxmlformats.org/drawingml/2006/main">
             <a:pPr>
+              <a:buNone/>
               <a:defRPr sz="3600" b="1">
                 <a:solidFill>
                   <a:srgbClr val="FF5F6D"/>
@@ -3657,6 +3684,7 @@
           <a:lstStyle xmlns:a="http://schemas.openxmlformats.org/drawingml/2006/main"/>
           <a:p xmlns:a="http://schemas.openxmlformats.org/drawingml/2006/main">
             <a:pPr>
+              <a:buNone/>
               <a:defRPr sz="2175" b="1">
                 <a:solidFill>
                   <a:srgbClr val="F2FBFF"/>
@@ -3707,6 +3735,7 @@
           <a:lstStyle xmlns:a="http://schemas.openxmlformats.org/drawingml/2006/main"/>
           <a:p xmlns:a="http://schemas.openxmlformats.org/drawingml/2006/main">
             <a:pPr>
+              <a:buNone/>
               <a:defRPr sz="1500" b="0">
                 <a:solidFill>
                   <a:srgbClr val="8EB2C5"/>
@@ -3724,6 +3753,7 @@
           </a:p>
           <a:p xmlns:a="http://schemas.openxmlformats.org/drawingml/2006/main">
             <a:pPr>
+              <a:buNone/>
               <a:defRPr sz="1500" b="0">
                 <a:solidFill>
                   <a:srgbClr val="8EB2C5"/>
@@ -3774,6 +3804,7 @@
           <a:lstStyle xmlns:a="http://schemas.openxmlformats.org/drawingml/2006/main"/>
           <a:p xmlns:a="http://schemas.openxmlformats.org/drawingml/2006/main">
             <a:pPr>
+              <a:buNone/>
               <a:defRPr sz="3600" b="1">
                 <a:solidFill>
                   <a:srgbClr val="FFBE3D"/>
@@ -3824,6 +3855,7 @@
           <a:lstStyle xmlns:a="http://schemas.openxmlformats.org/drawingml/2006/main"/>
           <a:p xmlns:a="http://schemas.openxmlformats.org/drawingml/2006/main">
             <a:pPr>
+              <a:buNone/>
               <a:defRPr sz="2175" b="1">
                 <a:solidFill>
                   <a:srgbClr val="F2FBFF"/>
@@ -3874,6 +3906,7 @@
           <a:lstStyle xmlns:a="http://schemas.openxmlformats.org/drawingml/2006/main"/>
           <a:p xmlns:a="http://schemas.openxmlformats.org/drawingml/2006/main">
             <a:pPr>
+              <a:buNone/>
               <a:defRPr sz="1500" b="0">
                 <a:solidFill>
                   <a:srgbClr val="8EB2C5"/>
@@ -3891,6 +3924,7 @@
           </a:p>
           <a:p xmlns:a="http://schemas.openxmlformats.org/drawingml/2006/main">
             <a:pPr>
+              <a:buNone/>
               <a:defRPr sz="1500" b="0">
                 <a:solidFill>
                   <a:srgbClr val="8EB2C5"/>
@@ -3976,6 +4010,7 @@
           <a:lstStyle xmlns:a="http://schemas.openxmlformats.org/drawingml/2006/main"/>
           <a:p xmlns:a="http://schemas.openxmlformats.org/drawingml/2006/main">
             <a:pPr>
+              <a:buNone/>
               <a:defRPr sz="2100" b="1">
                 <a:solidFill>
                   <a:srgbClr val="13E6FF"/>
@@ -4086,6 +4121,7 @@
           <a:lstStyle xmlns:a="http://schemas.openxmlformats.org/drawingml/2006/main"/>
           <a:p xmlns:a="http://schemas.openxmlformats.org/drawingml/2006/main">
             <a:pPr>
+              <a:buNone/>
               <a:defRPr sz="1125" b="1">
                 <a:solidFill>
                   <a:srgbClr val="13E6FF"/>
@@ -4136,6 +4172,7 @@
           <a:lstStyle xmlns:a="http://schemas.openxmlformats.org/drawingml/2006/main"/>
           <a:p xmlns:a="http://schemas.openxmlformats.org/drawingml/2006/main">
             <a:pPr>
+              <a:buNone/>
               <a:defRPr sz="1125" b="1">
                 <a:solidFill>
                   <a:srgbClr val="8EB2C5"/>
@@ -4186,6 +4223,7 @@
           <a:lstStyle xmlns:a="http://schemas.openxmlformats.org/drawingml/2006/main"/>
           <a:p xmlns:a="http://schemas.openxmlformats.org/drawingml/2006/main">
             <a:pPr>
+              <a:buNone/>
               <a:defRPr sz="2850" b="1">
                 <a:solidFill>
                   <a:srgbClr val="F2FBFF"/>
@@ -4198,7 +4236,7 @@
                   <a:srgbClr val="F2FBFF"/>
                 </a:solidFill>
               </a:rPr>
-              <a:t>One trust chain connects source events to governed outcomes</a:t>
+              <a:t>Attestcoin makes source-chain inclusion independently verifiable</a:t>
             </a:r>
           </a:p>
         </p:txBody>
@@ -4267,6 +4305,7 @@
           <a:lstStyle xmlns:a="http://schemas.openxmlformats.org/drawingml/2006/main"/>
           <a:p xmlns:a="http://schemas.openxmlformats.org/drawingml/2006/main">
             <a:pPr>
+              <a:buNone/>
               <a:defRPr sz="900" b="1">
                 <a:solidFill>
                   <a:srgbClr val="8EB2C5"/>
@@ -4600,6 +4639,7 @@
           <a:lstStyle xmlns:a="http://schemas.openxmlformats.org/drawingml/2006/main"/>
           <a:p xmlns:a="http://schemas.openxmlformats.org/drawingml/2006/main">
             <a:pPr>
+              <a:buNone/>
               <a:defRPr sz="1350" b="1">
                 <a:solidFill>
                   <a:srgbClr val="24E0C2"/>
@@ -4650,6 +4690,7 @@
           <a:lstStyle xmlns:a="http://schemas.openxmlformats.org/drawingml/2006/main"/>
           <a:p xmlns:a="http://schemas.openxmlformats.org/drawingml/2006/main">
             <a:pPr>
+              <a:buNone/>
               <a:defRPr sz="1350" b="1">
                 <a:solidFill>
                   <a:srgbClr val="F2FBFF"/>
@@ -4662,11 +4703,12 @@
                   <a:srgbClr val="F2FBFF"/>
                 </a:solidFill>
               </a:rPr>
-              <a:t>Sepolia events</a:t>
-            </a:r>
-          </a:p>
-          <a:p xmlns:a="http://schemas.openxmlformats.org/drawingml/2006/main">
-            <a:pPr>
+              <a:t>Events stay on</a:t>
+            </a:r>
+          </a:p>
+          <a:p xmlns:a="http://schemas.openxmlformats.org/drawingml/2006/main">
+            <a:pPr>
+              <a:buNone/>
               <a:defRPr sz="1350" b="1">
                 <a:solidFill>
                   <a:srgbClr val="F2FBFF"/>
@@ -4679,7 +4721,7 @@
                   <a:srgbClr val="F2FBFF"/>
                 </a:solidFill>
               </a:rPr>
-              <a:t>and observations</a:t>
+              <a:t>the source chain</a:t>
             </a:r>
           </a:p>
         </p:txBody>
@@ -4752,6 +4794,7 @@
           <a:lstStyle xmlns:a="http://schemas.openxmlformats.org/drawingml/2006/main"/>
           <a:p xmlns:a="http://schemas.openxmlformats.org/drawingml/2006/main">
             <a:pPr>
+              <a:buNone/>
               <a:defRPr sz="1350" b="1">
                 <a:solidFill>
                   <a:srgbClr val="13E6FF"/>
@@ -4802,6 +4845,7 @@
           <a:lstStyle xmlns:a="http://schemas.openxmlformats.org/drawingml/2006/main"/>
           <a:p xmlns:a="http://schemas.openxmlformats.org/drawingml/2006/main">
             <a:pPr>
+              <a:buNone/>
               <a:defRPr sz="1350" b="1">
                 <a:solidFill>
                   <a:srgbClr val="F2FBFF"/>
@@ -4814,24 +4858,25 @@
                   <a:srgbClr val="F2FBFF"/>
                 </a:solidFill>
               </a:rPr>
+              <a:t>Independent attestors</a:t>
+            </a:r>
+          </a:p>
+          <a:p xmlns:a="http://schemas.openxmlformats.org/drawingml/2006/main">
+            <a:pPr>
+              <a:buNone/>
+              <a:defRPr sz="1350" b="1">
+                <a:solidFill>
+                  <a:srgbClr val="F2FBFF"/>
+                </a:solidFill>
+              </a:defRPr>
+            </a:pPr>
+            <a:r>
+              <a:rPr sz="1350" b="1">
+                <a:solidFill>
+                  <a:srgbClr val="F2FBFF"/>
+                </a:solidFill>
+              </a:rPr>
               <a:t>Merkle + continuity</a:t>
-            </a:r>
-          </a:p>
-          <a:p xmlns:a="http://schemas.openxmlformats.org/drawingml/2006/main">
-            <a:pPr>
-              <a:defRPr sz="1350" b="1">
-                <a:solidFill>
-                  <a:srgbClr val="F2FBFF"/>
-                </a:solidFill>
-              </a:defRPr>
-            </a:pPr>
-            <a:r>
-              <a:rPr sz="1350" b="1">
-                <a:solidFill>
-                  <a:srgbClr val="F2FBFF"/>
-                </a:solidFill>
-              </a:rPr>
-              <a:t>proof verification</a:t>
             </a:r>
           </a:p>
         </p:txBody>
@@ -4904,6 +4949,7 @@
           <a:lstStyle xmlns:a="http://schemas.openxmlformats.org/drawingml/2006/main"/>
           <a:p xmlns:a="http://schemas.openxmlformats.org/drawingml/2006/main">
             <a:pPr>
+              <a:buNone/>
               <a:defRPr sz="1350" b="1">
                 <a:solidFill>
                   <a:srgbClr val="58F28B"/>
@@ -4954,6 +5000,7 @@
           <a:lstStyle xmlns:a="http://schemas.openxmlformats.org/drawingml/2006/main"/>
           <a:p xmlns:a="http://schemas.openxmlformats.org/drawingml/2006/main">
             <a:pPr>
+              <a:buNone/>
               <a:defRPr sz="1350" b="1">
                 <a:solidFill>
                   <a:srgbClr val="F2FBFF"/>
@@ -4966,11 +5013,12 @@
                   <a:srgbClr val="F2FBFF"/>
                 </a:solidFill>
               </a:rPr>
-              <a:t>Immutable tenant</a:t>
-            </a:r>
-          </a:p>
-          <a:p xmlns:a="http://schemas.openxmlformats.org/drawingml/2006/main">
-            <a:pPr>
+              <a:t>Verified inclusion</a:t>
+            </a:r>
+          </a:p>
+          <a:p xmlns:a="http://schemas.openxmlformats.org/drawingml/2006/main">
+            <a:pPr>
+              <a:buNone/>
               <a:defRPr sz="1350" b="1">
                 <a:solidFill>
                   <a:srgbClr val="F2FBFF"/>
@@ -4983,7 +5031,7 @@
                   <a:srgbClr val="F2FBFF"/>
                 </a:solidFill>
               </a:rPr>
-              <a:t>facts + snapshots</a:t>
+              <a:t>no bridge custody</a:t>
             </a:r>
           </a:p>
         </p:txBody>
@@ -5056,6 +5104,7 @@
           <a:lstStyle xmlns:a="http://schemas.openxmlformats.org/drawingml/2006/main"/>
           <a:p xmlns:a="http://schemas.openxmlformats.org/drawingml/2006/main">
             <a:pPr>
+              <a:buNone/>
               <a:defRPr sz="1350" b="1">
                 <a:solidFill>
                   <a:srgbClr val="A875FF"/>
@@ -5106,6 +5155,7 @@
           <a:lstStyle xmlns:a="http://schemas.openxmlformats.org/drawingml/2006/main"/>
           <a:p xmlns:a="http://schemas.openxmlformats.org/drawingml/2006/main">
             <a:pPr>
+              <a:buNone/>
               <a:defRPr sz="1350" b="1">
                 <a:solidFill>
                   <a:srgbClr val="F2FBFF"/>
@@ -5123,6 +5173,7 @@
           </a:p>
           <a:p xmlns:a="http://schemas.openxmlformats.org/drawingml/2006/main">
             <a:pPr>
+              <a:buNone/>
               <a:defRPr sz="1350" b="1">
                 <a:solidFill>
                   <a:srgbClr val="F2FBFF"/>
@@ -5208,6 +5259,7 @@
           <a:lstStyle xmlns:a="http://schemas.openxmlformats.org/drawingml/2006/main"/>
           <a:p xmlns:a="http://schemas.openxmlformats.org/drawingml/2006/main">
             <a:pPr>
+              <a:buNone/>
               <a:defRPr sz="1350" b="1">
                 <a:solidFill>
                   <a:srgbClr val="FFBE3D"/>
@@ -5258,6 +5310,7 @@
           <a:lstStyle xmlns:a="http://schemas.openxmlformats.org/drawingml/2006/main"/>
           <a:p xmlns:a="http://schemas.openxmlformats.org/drawingml/2006/main">
             <a:pPr>
+              <a:buNone/>
               <a:defRPr sz="1350" b="1">
                 <a:solidFill>
                   <a:srgbClr val="F2FBFF"/>
@@ -5275,6 +5328,7 @@
           </a:p>
           <a:p xmlns:a="http://schemas.openxmlformats.org/drawingml/2006/main">
             <a:pPr>
+              <a:buNone/>
               <a:defRPr sz="1350" b="1">
                 <a:solidFill>
                   <a:srgbClr val="F2FBFF"/>
@@ -5325,6 +5379,7 @@
           <a:lstStyle xmlns:a="http://schemas.openxmlformats.org/drawingml/2006/main"/>
           <a:p xmlns:a="http://schemas.openxmlformats.org/drawingml/2006/main">
             <a:pPr>
+              <a:buNone/>
               <a:defRPr sz="1650" b="1">
                 <a:solidFill>
                   <a:srgbClr val="8EB2C5"/>
@@ -5337,7 +5392,7 @@
                   <a:srgbClr val="8EB2C5"/>
                 </a:solidFill>
               </a:rPr>
-              <a:t>organization_id isolation  ·  immutable lineage  ·  deterministic refusal</a:t>
+              <a:t>anti-forgery proof  ·  continuity freshness  ·  replay-safe lineage  ·  tenant isolation</a:t>
             </a:r>
           </a:p>
         </p:txBody>
@@ -5410,6 +5465,7 @@
           <a:lstStyle xmlns:a="http://schemas.openxmlformats.org/drawingml/2006/main"/>
           <a:p xmlns:a="http://schemas.openxmlformats.org/drawingml/2006/main">
             <a:pPr>
+              <a:buNone/>
               <a:defRPr sz="1050" b="1">
                 <a:solidFill>
                   <a:srgbClr val="FF5F6D"/>
@@ -5422,7 +5478,7 @@
                   <a:srgbClr val="FF5F6D"/>
                 </a:solidFill>
               </a:rPr>
-              <a:t>NO PRIVATE KEY</a:t>
+              <a:t>NO BRIDGE CUSTODY</a:t>
             </a:r>
           </a:p>
         </p:txBody>
@@ -5495,6 +5551,7 @@
           <a:lstStyle xmlns:a="http://schemas.openxmlformats.org/drawingml/2006/main"/>
           <a:p xmlns:a="http://schemas.openxmlformats.org/drawingml/2006/main">
             <a:pPr>
+              <a:buNone/>
               <a:defRPr sz="1050" b="1">
                 <a:solidFill>
                   <a:srgbClr val="FF5F6D"/>
@@ -5507,7 +5564,7 @@
                   <a:srgbClr val="FF5F6D"/>
                 </a:solidFill>
               </a:rPr>
-              <a:t>NO AUTO-BROADCAST</a:t>
+              <a:t>NO ORACLE OPERATOR</a:t>
             </a:r>
           </a:p>
         </p:txBody>
@@ -5580,6 +5637,7 @@
           <a:lstStyle xmlns:a="http://schemas.openxmlformats.org/drawingml/2006/main"/>
           <a:p xmlns:a="http://schemas.openxmlformats.org/drawingml/2006/main">
             <a:pPr>
+              <a:buNone/>
               <a:defRPr sz="1050" b="1">
                 <a:solidFill>
                   <a:srgbClr val="FFBE3D"/>
@@ -5592,7 +5650,7 @@
                   <a:srgbClr val="FFBE3D"/>
                 </a:solidFill>
               </a:rPr>
-              <a:t>HUMAN / DAO FINALITY</a:t>
+              <a:t>NO AI SIGNER</a:t>
             </a:r>
           </a:p>
         </p:txBody>
@@ -5690,6 +5748,7 @@
           <a:lstStyle xmlns:a="http://schemas.openxmlformats.org/drawingml/2006/main"/>
           <a:p xmlns:a="http://schemas.openxmlformats.org/drawingml/2006/main">
             <a:pPr>
+              <a:buNone/>
               <a:defRPr sz="1125" b="1">
                 <a:solidFill>
                   <a:srgbClr val="13E6FF"/>
@@ -5740,6 +5799,7 @@
           <a:lstStyle xmlns:a="http://schemas.openxmlformats.org/drawingml/2006/main"/>
           <a:p xmlns:a="http://schemas.openxmlformats.org/drawingml/2006/main">
             <a:pPr>
+              <a:buNone/>
               <a:defRPr sz="1125" b="1">
                 <a:solidFill>
                   <a:srgbClr val="8EB2C5"/>
@@ -5790,6 +5850,7 @@
           <a:lstStyle xmlns:a="http://schemas.openxmlformats.org/drawingml/2006/main"/>
           <a:p xmlns:a="http://schemas.openxmlformats.org/drawingml/2006/main">
             <a:pPr>
+              <a:buNone/>
               <a:defRPr sz="2850" b="1">
                 <a:solidFill>
                   <a:srgbClr val="F2FBFF"/>
@@ -5840,6 +5901,7 @@
           <a:lstStyle xmlns:a="http://schemas.openxmlformats.org/drawingml/2006/main"/>
           <a:p xmlns:a="http://schemas.openxmlformats.org/drawingml/2006/main">
             <a:pPr>
+              <a:buNone/>
               <a:defRPr sz="1500" b="0">
                 <a:solidFill>
                   <a:srgbClr val="8EB2C5"/>
@@ -5921,6 +5983,7 @@
           <a:lstStyle xmlns:a="http://schemas.openxmlformats.org/drawingml/2006/main"/>
           <a:p xmlns:a="http://schemas.openxmlformats.org/drawingml/2006/main">
             <a:pPr>
+              <a:buNone/>
               <a:defRPr sz="900" b="1">
                 <a:solidFill>
                   <a:srgbClr val="8EB2C5"/>
@@ -5971,6 +6034,7 @@
           <a:lstStyle xmlns:a="http://schemas.openxmlformats.org/drawingml/2006/main"/>
           <a:p xmlns:a="http://schemas.openxmlformats.org/drawingml/2006/main">
             <a:pPr>
+              <a:buNone/>
               <a:defRPr sz="1650" b="1">
                 <a:solidFill>
                   <a:srgbClr val="24E0C2"/>
@@ -6052,6 +6116,7 @@
           <a:lstStyle xmlns:a="http://schemas.openxmlformats.org/drawingml/2006/main"/>
           <a:p xmlns:a="http://schemas.openxmlformats.org/drawingml/2006/main">
             <a:pPr>
+              <a:buNone/>
               <a:defRPr sz="1650" b="1">
                 <a:solidFill>
                   <a:srgbClr val="F2FBFF"/>
@@ -6102,6 +6167,7 @@
           <a:lstStyle xmlns:a="http://schemas.openxmlformats.org/drawingml/2006/main"/>
           <a:p xmlns:a="http://schemas.openxmlformats.org/drawingml/2006/main">
             <a:pPr>
+              <a:buNone/>
               <a:defRPr sz="1500" b="1">
                 <a:solidFill>
                   <a:srgbClr val="24E0C2"/>
@@ -6152,6 +6218,7 @@
           <a:lstStyle xmlns:a="http://schemas.openxmlformats.org/drawingml/2006/main"/>
           <a:p xmlns:a="http://schemas.openxmlformats.org/drawingml/2006/main">
             <a:pPr>
+              <a:buNone/>
               <a:defRPr sz="1650" b="1">
                 <a:solidFill>
                   <a:srgbClr val="13E6FF"/>
@@ -6233,6 +6300,7 @@
           <a:lstStyle xmlns:a="http://schemas.openxmlformats.org/drawingml/2006/main"/>
           <a:p xmlns:a="http://schemas.openxmlformats.org/drawingml/2006/main">
             <a:pPr>
+              <a:buNone/>
               <a:defRPr sz="1650" b="1">
                 <a:solidFill>
                   <a:srgbClr val="F2FBFF"/>
@@ -6283,6 +6351,7 @@
           <a:lstStyle xmlns:a="http://schemas.openxmlformats.org/drawingml/2006/main"/>
           <a:p xmlns:a="http://schemas.openxmlformats.org/drawingml/2006/main">
             <a:pPr>
+              <a:buNone/>
               <a:defRPr sz="1500" b="1">
                 <a:solidFill>
                   <a:srgbClr val="13E6FF"/>
@@ -6333,6 +6402,7 @@
           <a:lstStyle xmlns:a="http://schemas.openxmlformats.org/drawingml/2006/main"/>
           <a:p xmlns:a="http://schemas.openxmlformats.org/drawingml/2006/main">
             <a:pPr>
+              <a:buNone/>
               <a:defRPr sz="1650" b="1">
                 <a:solidFill>
                   <a:srgbClr val="58F28B"/>
@@ -6414,6 +6484,7 @@
           <a:lstStyle xmlns:a="http://schemas.openxmlformats.org/drawingml/2006/main"/>
           <a:p xmlns:a="http://schemas.openxmlformats.org/drawingml/2006/main">
             <a:pPr>
+              <a:buNone/>
               <a:defRPr sz="1650" b="1">
                 <a:solidFill>
                   <a:srgbClr val="F2FBFF"/>
@@ -6464,6 +6535,7 @@
           <a:lstStyle xmlns:a="http://schemas.openxmlformats.org/drawingml/2006/main"/>
           <a:p xmlns:a="http://schemas.openxmlformats.org/drawingml/2006/main">
             <a:pPr>
+              <a:buNone/>
               <a:defRPr sz="1500" b="1">
                 <a:solidFill>
                   <a:srgbClr val="58F28B"/>
@@ -6514,6 +6586,7 @@
           <a:lstStyle xmlns:a="http://schemas.openxmlformats.org/drawingml/2006/main"/>
           <a:p xmlns:a="http://schemas.openxmlformats.org/drawingml/2006/main">
             <a:pPr>
+              <a:buNone/>
               <a:defRPr sz="1650" b="1">
                 <a:solidFill>
                   <a:srgbClr val="A875FF"/>
@@ -6595,6 +6668,7 @@
           <a:lstStyle xmlns:a="http://schemas.openxmlformats.org/drawingml/2006/main"/>
           <a:p xmlns:a="http://schemas.openxmlformats.org/drawingml/2006/main">
             <a:pPr>
+              <a:buNone/>
               <a:defRPr sz="1650" b="1">
                 <a:solidFill>
                   <a:srgbClr val="F2FBFF"/>
@@ -6645,6 +6719,7 @@
           <a:lstStyle xmlns:a="http://schemas.openxmlformats.org/drawingml/2006/main"/>
           <a:p xmlns:a="http://schemas.openxmlformats.org/drawingml/2006/main">
             <a:pPr>
+              <a:buNone/>
               <a:defRPr sz="1500" b="1">
                 <a:solidFill>
                   <a:srgbClr val="A875FF"/>
@@ -6695,6 +6770,7 @@
           <a:lstStyle xmlns:a="http://schemas.openxmlformats.org/drawingml/2006/main"/>
           <a:p xmlns:a="http://schemas.openxmlformats.org/drawingml/2006/main">
             <a:pPr>
+              <a:buNone/>
               <a:defRPr sz="1650" b="1">
                 <a:solidFill>
                   <a:srgbClr val="FFBE3D"/>
@@ -6776,6 +6852,7 @@
           <a:lstStyle xmlns:a="http://schemas.openxmlformats.org/drawingml/2006/main"/>
           <a:p xmlns:a="http://schemas.openxmlformats.org/drawingml/2006/main">
             <a:pPr>
+              <a:buNone/>
               <a:defRPr sz="1650" b="1">
                 <a:solidFill>
                   <a:srgbClr val="F2FBFF"/>
@@ -6826,6 +6903,7 @@
           <a:lstStyle xmlns:a="http://schemas.openxmlformats.org/drawingml/2006/main"/>
           <a:p xmlns:a="http://schemas.openxmlformats.org/drawingml/2006/main">
             <a:pPr>
+              <a:buNone/>
               <a:defRPr sz="1500" b="1">
                 <a:solidFill>
                   <a:srgbClr val="FFBE3D"/>
@@ -6911,6 +6989,7 @@
           <a:lstStyle xmlns:a="http://schemas.openxmlformats.org/drawingml/2006/main"/>
           <a:p xmlns:a="http://schemas.openxmlformats.org/drawingml/2006/main">
             <a:pPr>
+              <a:buNone/>
               <a:defRPr sz="1050" b="1">
                 <a:solidFill>
                   <a:srgbClr val="58F28B"/>
@@ -7021,6 +7100,7 @@
           <a:lstStyle xmlns:a="http://schemas.openxmlformats.org/drawingml/2006/main"/>
           <a:p xmlns:a="http://schemas.openxmlformats.org/drawingml/2006/main">
             <a:pPr>
+              <a:buNone/>
               <a:defRPr sz="1125" b="1">
                 <a:solidFill>
                   <a:srgbClr val="13E6FF"/>
@@ -7071,6 +7151,7 @@
           <a:lstStyle xmlns:a="http://schemas.openxmlformats.org/drawingml/2006/main"/>
           <a:p xmlns:a="http://schemas.openxmlformats.org/drawingml/2006/main">
             <a:pPr>
+              <a:buNone/>
               <a:defRPr sz="1125" b="1">
                 <a:solidFill>
                   <a:srgbClr val="8EB2C5"/>
@@ -7121,6 +7202,7 @@
           <a:lstStyle xmlns:a="http://schemas.openxmlformats.org/drawingml/2006/main"/>
           <a:p xmlns:a="http://schemas.openxmlformats.org/drawingml/2006/main">
             <a:pPr>
+              <a:buNone/>
               <a:defRPr sz="2850" b="1">
                 <a:solidFill>
                   <a:srgbClr val="F2FBFF"/>
@@ -7171,6 +7253,7 @@
           <a:lstStyle xmlns:a="http://schemas.openxmlformats.org/drawingml/2006/main"/>
           <a:p xmlns:a="http://schemas.openxmlformats.org/drawingml/2006/main">
             <a:pPr>
+              <a:buNone/>
               <a:defRPr sz="1500" b="0">
                 <a:solidFill>
                   <a:srgbClr val="8EB2C5"/>
@@ -7252,6 +7335,7 @@
           <a:lstStyle xmlns:a="http://schemas.openxmlformats.org/drawingml/2006/main"/>
           <a:p xmlns:a="http://schemas.openxmlformats.org/drawingml/2006/main">
             <a:pPr>
+              <a:buNone/>
               <a:defRPr sz="900" b="1">
                 <a:solidFill>
                   <a:srgbClr val="8EB2C5"/>
@@ -7337,6 +7421,7 @@
           <a:lstStyle xmlns:a="http://schemas.openxmlformats.org/drawingml/2006/main"/>
           <a:p xmlns:a="http://schemas.openxmlformats.org/drawingml/2006/main">
             <a:pPr>
+              <a:buNone/>
               <a:defRPr sz="1200" b="1">
                 <a:solidFill>
                   <a:srgbClr val="24E0C2"/>
@@ -7387,6 +7472,7 @@
           <a:lstStyle xmlns:a="http://schemas.openxmlformats.org/drawingml/2006/main"/>
           <a:p xmlns:a="http://schemas.openxmlformats.org/drawingml/2006/main">
             <a:pPr>
+              <a:buNone/>
               <a:defRPr sz="1800" b="1">
                 <a:solidFill>
                   <a:srgbClr val="F2FBFF"/>
@@ -7437,6 +7523,7 @@
           <a:lstStyle xmlns:a="http://schemas.openxmlformats.org/drawingml/2006/main"/>
           <a:p xmlns:a="http://schemas.openxmlformats.org/drawingml/2006/main">
             <a:pPr>
+              <a:buNone/>
               <a:defRPr sz="2250" b="1">
                 <a:solidFill>
                   <a:srgbClr val="24E0C2"/>
@@ -7487,6 +7574,7 @@
           <a:lstStyle xmlns:a="http://schemas.openxmlformats.org/drawingml/2006/main"/>
           <a:p xmlns:a="http://schemas.openxmlformats.org/drawingml/2006/main">
             <a:pPr>
+              <a:buNone/>
               <a:defRPr sz="1275" b="0">
                 <a:solidFill>
                   <a:srgbClr val="8EB2C5"/>
@@ -7572,6 +7660,7 @@
           <a:lstStyle xmlns:a="http://schemas.openxmlformats.org/drawingml/2006/main"/>
           <a:p xmlns:a="http://schemas.openxmlformats.org/drawingml/2006/main">
             <a:pPr>
+              <a:buNone/>
               <a:defRPr sz="1200" b="1">
                 <a:solidFill>
                   <a:srgbClr val="13E6FF"/>
@@ -7622,6 +7711,7 @@
           <a:lstStyle xmlns:a="http://schemas.openxmlformats.org/drawingml/2006/main"/>
           <a:p xmlns:a="http://schemas.openxmlformats.org/drawingml/2006/main">
             <a:pPr>
+              <a:buNone/>
               <a:defRPr sz="1800" b="1">
                 <a:solidFill>
                   <a:srgbClr val="F2FBFF"/>
@@ -7672,6 +7762,7 @@
           <a:lstStyle xmlns:a="http://schemas.openxmlformats.org/drawingml/2006/main"/>
           <a:p xmlns:a="http://schemas.openxmlformats.org/drawingml/2006/main">
             <a:pPr>
+              <a:buNone/>
               <a:defRPr sz="2250" b="1">
                 <a:solidFill>
                   <a:srgbClr val="13E6FF"/>
@@ -7722,6 +7813,7 @@
           <a:lstStyle xmlns:a="http://schemas.openxmlformats.org/drawingml/2006/main"/>
           <a:p xmlns:a="http://schemas.openxmlformats.org/drawingml/2006/main">
             <a:pPr>
+              <a:buNone/>
               <a:defRPr sz="1275" b="0">
                 <a:solidFill>
                   <a:srgbClr val="8EB2C5"/>
@@ -7807,6 +7899,7 @@
           <a:lstStyle xmlns:a="http://schemas.openxmlformats.org/drawingml/2006/main"/>
           <a:p xmlns:a="http://schemas.openxmlformats.org/drawingml/2006/main">
             <a:pPr>
+              <a:buNone/>
               <a:defRPr sz="1200" b="1">
                 <a:solidFill>
                   <a:srgbClr val="A875FF"/>
@@ -7857,6 +7950,7 @@
           <a:lstStyle xmlns:a="http://schemas.openxmlformats.org/drawingml/2006/main"/>
           <a:p xmlns:a="http://schemas.openxmlformats.org/drawingml/2006/main">
             <a:pPr>
+              <a:buNone/>
               <a:defRPr sz="1800" b="1">
                 <a:solidFill>
                   <a:srgbClr val="F2FBFF"/>
@@ -7907,6 +8001,7 @@
           <a:lstStyle xmlns:a="http://schemas.openxmlformats.org/drawingml/2006/main"/>
           <a:p xmlns:a="http://schemas.openxmlformats.org/drawingml/2006/main">
             <a:pPr>
+              <a:buNone/>
               <a:defRPr sz="2250" b="1">
                 <a:solidFill>
                   <a:srgbClr val="A875FF"/>
@@ -7957,6 +8052,7 @@
           <a:lstStyle xmlns:a="http://schemas.openxmlformats.org/drawingml/2006/main"/>
           <a:p xmlns:a="http://schemas.openxmlformats.org/drawingml/2006/main">
             <a:pPr>
+              <a:buNone/>
               <a:defRPr sz="1275" b="0">
                 <a:solidFill>
                   <a:srgbClr val="8EB2C5"/>
@@ -8007,6 +8103,7 @@
           <a:lstStyle xmlns:a="http://schemas.openxmlformats.org/drawingml/2006/main"/>
           <a:p xmlns:a="http://schemas.openxmlformats.org/drawingml/2006/main">
             <a:pPr>
+              <a:buNone/>
               <a:defRPr sz="1500" b="1">
                 <a:solidFill>
                   <a:srgbClr val="8EB2C5"/>
@@ -8117,6 +8214,7 @@
           <a:lstStyle xmlns:a="http://schemas.openxmlformats.org/drawingml/2006/main"/>
           <a:p xmlns:a="http://schemas.openxmlformats.org/drawingml/2006/main">
             <a:pPr>
+              <a:buNone/>
               <a:defRPr sz="1125" b="1">
                 <a:solidFill>
                   <a:srgbClr val="13E6FF"/>
@@ -8167,6 +8265,7 @@
           <a:lstStyle xmlns:a="http://schemas.openxmlformats.org/drawingml/2006/main"/>
           <a:p xmlns:a="http://schemas.openxmlformats.org/drawingml/2006/main">
             <a:pPr>
+              <a:buNone/>
               <a:defRPr sz="1125" b="1">
                 <a:solidFill>
                   <a:srgbClr val="8EB2C5"/>
@@ -8217,6 +8316,7 @@
           <a:lstStyle xmlns:a="http://schemas.openxmlformats.org/drawingml/2006/main"/>
           <a:p xmlns:a="http://schemas.openxmlformats.org/drawingml/2006/main">
             <a:pPr>
+              <a:buNone/>
               <a:defRPr sz="2850" b="1">
                 <a:solidFill>
                   <a:srgbClr val="F2FBFF"/>
@@ -8298,6 +8398,7 @@
           <a:lstStyle xmlns:a="http://schemas.openxmlformats.org/drawingml/2006/main"/>
           <a:p xmlns:a="http://schemas.openxmlformats.org/drawingml/2006/main">
             <a:pPr>
+              <a:buNone/>
               <a:defRPr sz="900" b="1">
                 <a:solidFill>
                   <a:srgbClr val="8EB2C5"/>
@@ -8414,6 +8515,7 @@
           <a:lstStyle xmlns:a="http://schemas.openxmlformats.org/drawingml/2006/main"/>
           <a:p xmlns:a="http://schemas.openxmlformats.org/drawingml/2006/main">
             <a:pPr>
+              <a:buNone/>
               <a:defRPr sz="1200" b="1">
                 <a:solidFill>
                   <a:srgbClr val="A875FF"/>
@@ -8530,6 +8632,7 @@
           <a:lstStyle xmlns:a="http://schemas.openxmlformats.org/drawingml/2006/main"/>
           <a:p xmlns:a="http://schemas.openxmlformats.org/drawingml/2006/main">
             <a:pPr>
+              <a:buNone/>
               <a:defRPr sz="1200" b="1">
                 <a:solidFill>
                   <a:srgbClr val="13E6FF"/>
@@ -8646,6 +8749,7 @@
           <a:lstStyle xmlns:a="http://schemas.openxmlformats.org/drawingml/2006/main"/>
           <a:p xmlns:a="http://schemas.openxmlformats.org/drawingml/2006/main">
             <a:pPr>
+              <a:buNone/>
               <a:defRPr sz="1200" b="1">
                 <a:solidFill>
                   <a:srgbClr val="24E0C2"/>
@@ -8762,6 +8866,7 @@
           <a:lstStyle xmlns:a="http://schemas.openxmlformats.org/drawingml/2006/main"/>
           <a:p xmlns:a="http://schemas.openxmlformats.org/drawingml/2006/main">
             <a:pPr>
+              <a:buNone/>
               <a:defRPr sz="1200" b="1">
                 <a:solidFill>
                   <a:srgbClr val="FFBE3D"/>
@@ -8847,6 +8952,7 @@
           <a:lstStyle xmlns:a="http://schemas.openxmlformats.org/drawingml/2006/main"/>
           <a:p xmlns:a="http://schemas.openxmlformats.org/drawingml/2006/main">
             <a:pPr>
+              <a:buNone/>
               <a:defRPr sz="1200" b="1">
                 <a:solidFill>
                   <a:srgbClr val="58F28B"/>
@@ -8897,6 +9003,7 @@
           <a:lstStyle xmlns:a="http://schemas.openxmlformats.org/drawingml/2006/main"/>
           <a:p xmlns:a="http://schemas.openxmlformats.org/drawingml/2006/main">
             <a:pPr>
+              <a:buNone/>
               <a:defRPr sz="1350" b="1">
                 <a:solidFill>
                   <a:srgbClr val="FFBE3D"/>
@@ -8947,6 +9054,7 @@
           <a:lstStyle xmlns:a="http://schemas.openxmlformats.org/drawingml/2006/main"/>
           <a:p xmlns:a="http://schemas.openxmlformats.org/drawingml/2006/main">
             <a:pPr>
+              <a:buNone/>
               <a:defRPr sz="1725" b="1">
                 <a:solidFill>
                   <a:srgbClr val="F2FBFF"/>
@@ -8997,6 +9105,7 @@
           <a:lstStyle xmlns:a="http://schemas.openxmlformats.org/drawingml/2006/main"/>
           <a:p xmlns:a="http://schemas.openxmlformats.org/drawingml/2006/main">
             <a:pPr>
+              <a:buNone/>
               <a:defRPr sz="1575" b="0">
                 <a:solidFill>
                   <a:srgbClr val="8EB2C5"/>
@@ -9082,6 +9191,7 @@
           <a:lstStyle xmlns:a="http://schemas.openxmlformats.org/drawingml/2006/main"/>
           <a:p xmlns:a="http://schemas.openxmlformats.org/drawingml/2006/main">
             <a:pPr>
+              <a:buNone/>
               <a:defRPr sz="1050" b="1">
                 <a:solidFill>
                   <a:srgbClr val="FF5F6D"/>
@@ -9192,6 +9302,7 @@
           <a:lstStyle xmlns:a="http://schemas.openxmlformats.org/drawingml/2006/main"/>
           <a:p xmlns:a="http://schemas.openxmlformats.org/drawingml/2006/main">
             <a:pPr>
+              <a:buNone/>
               <a:defRPr sz="1125" b="1">
                 <a:solidFill>
                   <a:srgbClr val="13E6FF"/>
@@ -9242,6 +9353,7 @@
           <a:lstStyle xmlns:a="http://schemas.openxmlformats.org/drawingml/2006/main"/>
           <a:p xmlns:a="http://schemas.openxmlformats.org/drawingml/2006/main">
             <a:pPr>
+              <a:buNone/>
               <a:defRPr sz="1125" b="1">
                 <a:solidFill>
                   <a:srgbClr val="8EB2C5"/>
@@ -9292,6 +9404,7 @@
           <a:lstStyle xmlns:a="http://schemas.openxmlformats.org/drawingml/2006/main"/>
           <a:p xmlns:a="http://schemas.openxmlformats.org/drawingml/2006/main">
             <a:pPr>
+              <a:buNone/>
               <a:defRPr sz="2850" b="1">
                 <a:solidFill>
                   <a:srgbClr val="F2FBFF"/>
@@ -9342,6 +9455,7 @@
           <a:lstStyle xmlns:a="http://schemas.openxmlformats.org/drawingml/2006/main"/>
           <a:p xmlns:a="http://schemas.openxmlformats.org/drawingml/2006/main">
             <a:pPr>
+              <a:buNone/>
               <a:defRPr sz="1500" b="0">
                 <a:solidFill>
                   <a:srgbClr val="8EB2C5"/>
@@ -9423,6 +9537,7 @@
           <a:lstStyle xmlns:a="http://schemas.openxmlformats.org/drawingml/2006/main"/>
           <a:p xmlns:a="http://schemas.openxmlformats.org/drawingml/2006/main">
             <a:pPr>
+              <a:buNone/>
               <a:defRPr sz="900" b="1">
                 <a:solidFill>
                   <a:srgbClr val="8EB2C5"/>
@@ -9473,6 +9588,7 @@
           <a:lstStyle xmlns:a="http://schemas.openxmlformats.org/drawingml/2006/main"/>
           <a:p xmlns:a="http://schemas.openxmlformats.org/drawingml/2006/main">
             <a:pPr>
+              <a:buNone/>
               <a:defRPr sz="1350" b="1">
                 <a:solidFill>
                   <a:srgbClr val="13E6FF"/>
@@ -9523,6 +9639,7 @@
           <a:lstStyle xmlns:a="http://schemas.openxmlformats.org/drawingml/2006/main"/>
           <a:p xmlns:a="http://schemas.openxmlformats.org/drawingml/2006/main">
             <a:pPr>
+              <a:buNone/>
               <a:defRPr sz="1725" b="1">
                 <a:solidFill>
                   <a:srgbClr val="F2FBFF"/>
@@ -9573,6 +9690,7 @@
           <a:lstStyle xmlns:a="http://schemas.openxmlformats.org/drawingml/2006/main"/>
           <a:p xmlns:a="http://schemas.openxmlformats.org/drawingml/2006/main">
             <a:pPr>
+              <a:buNone/>
               <a:defRPr sz="1275" b="1">
                 <a:solidFill>
                   <a:srgbClr val="13E6FF"/>
@@ -9654,6 +9772,7 @@
           <a:lstStyle xmlns:a="http://schemas.openxmlformats.org/drawingml/2006/main"/>
           <a:p xmlns:a="http://schemas.openxmlformats.org/drawingml/2006/main">
             <a:pPr>
+              <a:buNone/>
               <a:defRPr sz="1350" b="1">
                 <a:solidFill>
                   <a:srgbClr val="24E0C2"/>
@@ -9704,6 +9823,7 @@
           <a:lstStyle xmlns:a="http://schemas.openxmlformats.org/drawingml/2006/main"/>
           <a:p xmlns:a="http://schemas.openxmlformats.org/drawingml/2006/main">
             <a:pPr>
+              <a:buNone/>
               <a:defRPr sz="1725" b="1">
                 <a:solidFill>
                   <a:srgbClr val="F2FBFF"/>
@@ -9754,6 +9874,7 @@
           <a:lstStyle xmlns:a="http://schemas.openxmlformats.org/drawingml/2006/main"/>
           <a:p xmlns:a="http://schemas.openxmlformats.org/drawingml/2006/main">
             <a:pPr>
+              <a:buNone/>
               <a:defRPr sz="1275" b="1">
                 <a:solidFill>
                   <a:srgbClr val="24E0C2"/>
@@ -9835,6 +9956,7 @@
           <a:lstStyle xmlns:a="http://schemas.openxmlformats.org/drawingml/2006/main"/>
           <a:p xmlns:a="http://schemas.openxmlformats.org/drawingml/2006/main">
             <a:pPr>
+              <a:buNone/>
               <a:defRPr sz="1350" b="1">
                 <a:solidFill>
                   <a:srgbClr val="FFBE3D"/>
@@ -9885,6 +10007,7 @@
           <a:lstStyle xmlns:a="http://schemas.openxmlformats.org/drawingml/2006/main"/>
           <a:p xmlns:a="http://schemas.openxmlformats.org/drawingml/2006/main">
             <a:pPr>
+              <a:buNone/>
               <a:defRPr sz="1725" b="1">
                 <a:solidFill>
                   <a:srgbClr val="F2FBFF"/>
@@ -9935,6 +10058,7 @@
           <a:lstStyle xmlns:a="http://schemas.openxmlformats.org/drawingml/2006/main"/>
           <a:p xmlns:a="http://schemas.openxmlformats.org/drawingml/2006/main">
             <a:pPr>
+              <a:buNone/>
               <a:defRPr sz="1275" b="1">
                 <a:solidFill>
                   <a:srgbClr val="FFBE3D"/>
@@ -10016,6 +10140,7 @@
           <a:lstStyle xmlns:a="http://schemas.openxmlformats.org/drawingml/2006/main"/>
           <a:p xmlns:a="http://schemas.openxmlformats.org/drawingml/2006/main">
             <a:pPr>
+              <a:buNone/>
               <a:defRPr sz="1200" b="1">
                 <a:solidFill>
                   <a:srgbClr val="FF5F6D"/>
@@ -10066,6 +10191,7 @@
           <a:lstStyle xmlns:a="http://schemas.openxmlformats.org/drawingml/2006/main"/>
           <a:p xmlns:a="http://schemas.openxmlformats.org/drawingml/2006/main">
             <a:pPr>
+              <a:buNone/>
               <a:defRPr sz="1575" b="1">
                 <a:solidFill>
                   <a:srgbClr val="8EB2C5"/>
@@ -10176,6 +10302,7 @@
           <a:lstStyle xmlns:a="http://schemas.openxmlformats.org/drawingml/2006/main"/>
           <a:p xmlns:a="http://schemas.openxmlformats.org/drawingml/2006/main">
             <a:pPr>
+              <a:buNone/>
               <a:defRPr sz="1125" b="1">
                 <a:solidFill>
                   <a:srgbClr val="13E6FF"/>
@@ -10226,6 +10353,7 @@
           <a:lstStyle xmlns:a="http://schemas.openxmlformats.org/drawingml/2006/main"/>
           <a:p xmlns:a="http://schemas.openxmlformats.org/drawingml/2006/main">
             <a:pPr>
+              <a:buNone/>
               <a:defRPr sz="1125" b="1">
                 <a:solidFill>
                   <a:srgbClr val="8EB2C5"/>
@@ -10276,6 +10404,7 @@
           <a:lstStyle xmlns:a="http://schemas.openxmlformats.org/drawingml/2006/main"/>
           <a:p xmlns:a="http://schemas.openxmlformats.org/drawingml/2006/main">
             <a:pPr>
+              <a:buNone/>
               <a:defRPr sz="2850" b="1">
                 <a:solidFill>
                   <a:srgbClr val="F2FBFF"/>
@@ -10357,6 +10486,7 @@
           <a:lstStyle xmlns:a="http://schemas.openxmlformats.org/drawingml/2006/main"/>
           <a:p xmlns:a="http://schemas.openxmlformats.org/drawingml/2006/main">
             <a:pPr>
+              <a:buNone/>
               <a:defRPr sz="900" b="1">
                 <a:solidFill>
                   <a:srgbClr val="8EB2C5"/>
@@ -10407,6 +10537,7 @@
           <a:lstStyle xmlns:a="http://schemas.openxmlformats.org/drawingml/2006/main"/>
           <a:p xmlns:a="http://schemas.openxmlformats.org/drawingml/2006/main">
             <a:pPr>
+              <a:buNone/>
               <a:defRPr sz="3000" b="1">
                 <a:solidFill>
                   <a:srgbClr val="58F28B"/>
@@ -10457,6 +10588,7 @@
           <a:lstStyle xmlns:a="http://schemas.openxmlformats.org/drawingml/2006/main"/>
           <a:p xmlns:a="http://schemas.openxmlformats.org/drawingml/2006/main">
             <a:pPr>
+              <a:buNone/>
               <a:defRPr sz="1425" b="1">
                 <a:solidFill>
                   <a:srgbClr val="8EB2C5"/>
@@ -10507,6 +10639,7 @@
           <a:lstStyle xmlns:a="http://schemas.openxmlformats.org/drawingml/2006/main"/>
           <a:p xmlns:a="http://schemas.openxmlformats.org/drawingml/2006/main">
             <a:pPr>
+              <a:buNone/>
               <a:defRPr sz="3000" b="1">
                 <a:solidFill>
                   <a:srgbClr val="58F28B"/>
@@ -10557,6 +10690,7 @@
           <a:lstStyle xmlns:a="http://schemas.openxmlformats.org/drawingml/2006/main"/>
           <a:p xmlns:a="http://schemas.openxmlformats.org/drawingml/2006/main">
             <a:pPr>
+              <a:buNone/>
               <a:defRPr sz="1425" b="1">
                 <a:solidFill>
                   <a:srgbClr val="8EB2C5"/>
@@ -10607,6 +10741,7 @@
           <a:lstStyle xmlns:a="http://schemas.openxmlformats.org/drawingml/2006/main"/>
           <a:p xmlns:a="http://schemas.openxmlformats.org/drawingml/2006/main">
             <a:pPr>
+              <a:buNone/>
               <a:defRPr sz="3000" b="1">
                 <a:solidFill>
                   <a:srgbClr val="A875FF"/>
@@ -10657,6 +10792,7 @@
           <a:lstStyle xmlns:a="http://schemas.openxmlformats.org/drawingml/2006/main"/>
           <a:p xmlns:a="http://schemas.openxmlformats.org/drawingml/2006/main">
             <a:pPr>
+              <a:buNone/>
               <a:defRPr sz="1425" b="1">
                 <a:solidFill>
                   <a:srgbClr val="8EB2C5"/>
@@ -10707,6 +10843,7 @@
           <a:lstStyle xmlns:a="http://schemas.openxmlformats.org/drawingml/2006/main"/>
           <a:p xmlns:a="http://schemas.openxmlformats.org/drawingml/2006/main">
             <a:pPr>
+              <a:buNone/>
               <a:defRPr sz="3000" b="1">
                 <a:solidFill>
                   <a:srgbClr val="A875FF"/>
@@ -10757,6 +10894,7 @@
           <a:lstStyle xmlns:a="http://schemas.openxmlformats.org/drawingml/2006/main"/>
           <a:p xmlns:a="http://schemas.openxmlformats.org/drawingml/2006/main">
             <a:pPr>
+              <a:buNone/>
               <a:defRPr sz="1425" b="1">
                 <a:solidFill>
                   <a:srgbClr val="8EB2C5"/>
@@ -10807,6 +10945,7 @@
           <a:lstStyle xmlns:a="http://schemas.openxmlformats.org/drawingml/2006/main"/>
           <a:p xmlns:a="http://schemas.openxmlformats.org/drawingml/2006/main">
             <a:pPr>
+              <a:buNone/>
               <a:defRPr sz="3000" b="1">
                 <a:solidFill>
                   <a:srgbClr val="13E6FF"/>
@@ -10857,6 +10996,7 @@
           <a:lstStyle xmlns:a="http://schemas.openxmlformats.org/drawingml/2006/main"/>
           <a:p xmlns:a="http://schemas.openxmlformats.org/drawingml/2006/main">
             <a:pPr>
+              <a:buNone/>
               <a:defRPr sz="1425" b="1">
                 <a:solidFill>
                   <a:srgbClr val="8EB2C5"/>
@@ -10907,6 +11047,7 @@
           <a:lstStyle xmlns:a="http://schemas.openxmlformats.org/drawingml/2006/main"/>
           <a:p xmlns:a="http://schemas.openxmlformats.org/drawingml/2006/main">
             <a:pPr>
+              <a:buNone/>
               <a:defRPr sz="3000" b="1">
                 <a:solidFill>
                   <a:srgbClr val="58F28B"/>
@@ -10957,6 +11098,7 @@
           <a:lstStyle xmlns:a="http://schemas.openxmlformats.org/drawingml/2006/main"/>
           <a:p xmlns:a="http://schemas.openxmlformats.org/drawingml/2006/main">
             <a:pPr>
+              <a:buNone/>
               <a:defRPr sz="1425" b="1">
                 <a:solidFill>
                   <a:srgbClr val="8EB2C5"/>
@@ -11038,6 +11180,7 @@
           <a:lstStyle xmlns:a="http://schemas.openxmlformats.org/drawingml/2006/main"/>
           <a:p xmlns:a="http://schemas.openxmlformats.org/drawingml/2006/main">
             <a:pPr>
+              <a:buNone/>
               <a:defRPr sz="1575" b="1">
                 <a:solidFill>
                   <a:srgbClr val="F2FBFF"/>
@@ -11050,7 +11193,7 @@
                   <a:srgbClr val="F2FBFF"/>
                 </a:solidFill>
               </a:rPr>
-              <a:t>RLS isolation  ·  immutable snapshots  ·  append-only audit  ·  mutation rejection  ·  zero AI authority</a:t>
+              <a:t>Forgery→proof reject  ·  stale→fail closed  ·  replay→dedup  ·  cross-tenant→RLS  ·  AI→no signer</a:t>
             </a:r>
           </a:p>
         </p:txBody>
@@ -11148,6 +11291,7 @@
           <a:lstStyle xmlns:a="http://schemas.openxmlformats.org/drawingml/2006/main"/>
           <a:p xmlns:a="http://schemas.openxmlformats.org/drawingml/2006/main">
             <a:pPr>
+              <a:buNone/>
               <a:defRPr sz="1125" b="1">
                 <a:solidFill>
                   <a:srgbClr val="13E6FF"/>
@@ -11198,6 +11342,7 @@
           <a:lstStyle xmlns:a="http://schemas.openxmlformats.org/drawingml/2006/main"/>
           <a:p xmlns:a="http://schemas.openxmlformats.org/drawingml/2006/main">
             <a:pPr>
+              <a:buNone/>
               <a:defRPr sz="1125" b="1">
                 <a:solidFill>
                   <a:srgbClr val="8EB2C5"/>
@@ -11248,6 +11393,7 @@
           <a:lstStyle xmlns:a="http://schemas.openxmlformats.org/drawingml/2006/main"/>
           <a:p xmlns:a="http://schemas.openxmlformats.org/drawingml/2006/main">
             <a:pPr>
+              <a:buNone/>
               <a:defRPr sz="2850" b="1">
                 <a:solidFill>
                   <a:srgbClr val="F2FBFF"/>
@@ -11329,6 +11475,7 @@
           <a:lstStyle xmlns:a="http://schemas.openxmlformats.org/drawingml/2006/main"/>
           <a:p xmlns:a="http://schemas.openxmlformats.org/drawingml/2006/main">
             <a:pPr>
+              <a:buNone/>
               <a:defRPr sz="900" b="1">
                 <a:solidFill>
                   <a:srgbClr val="8EB2C5"/>
@@ -11379,6 +11526,7 @@
           <a:lstStyle xmlns:a="http://schemas.openxmlformats.org/drawingml/2006/main"/>
           <a:p xmlns:a="http://schemas.openxmlformats.org/drawingml/2006/main">
             <a:pPr>
+              <a:buNone/>
               <a:defRPr sz="1350" b="1">
                 <a:solidFill>
                   <a:srgbClr val="13E6FF"/>
@@ -11429,6 +11577,7 @@
           <a:lstStyle xmlns:a="http://schemas.openxmlformats.org/drawingml/2006/main"/>
           <a:p xmlns:a="http://schemas.openxmlformats.org/drawingml/2006/main">
             <a:pPr>
+              <a:buNone/>
               <a:defRPr sz="1950" b="1">
                 <a:solidFill>
                   <a:srgbClr val="F2FBFF"/>
@@ -11479,6 +11628,7 @@
           <a:lstStyle xmlns:a="http://schemas.openxmlformats.org/drawingml/2006/main"/>
           <a:p xmlns:a="http://schemas.openxmlformats.org/drawingml/2006/main">
             <a:pPr>
+              <a:buNone/>
               <a:defRPr sz="1500" b="0">
                 <a:solidFill>
                   <a:srgbClr val="8EB2C5"/>
@@ -11491,7 +11641,7 @@
                   <a:srgbClr val="8EB2C5"/>
                 </a:solidFill>
               </a:rPr>
-              <a:t>Source event → USC proof → TransactionVerified</a:t>
+              <a:t>Source event → stale proof rejected → fresh proof verified</a:t>
             </a:r>
           </a:p>
         </p:txBody>
@@ -11560,6 +11710,7 @@
           <a:lstStyle xmlns:a="http://schemas.openxmlformats.org/drawingml/2006/main"/>
           <a:p xmlns:a="http://schemas.openxmlformats.org/drawingml/2006/main">
             <a:pPr>
+              <a:buNone/>
               <a:defRPr sz="1350" b="1">
                 <a:solidFill>
                   <a:srgbClr val="A875FF"/>
@@ -11610,6 +11761,7 @@
           <a:lstStyle xmlns:a="http://schemas.openxmlformats.org/drawingml/2006/main"/>
           <a:p xmlns:a="http://schemas.openxmlformats.org/drawingml/2006/main">
             <a:pPr>
+              <a:buNone/>
               <a:defRPr sz="1950" b="1">
                 <a:solidFill>
                   <a:srgbClr val="F2FBFF"/>
@@ -11660,6 +11812,7 @@
           <a:lstStyle xmlns:a="http://schemas.openxmlformats.org/drawingml/2006/main"/>
           <a:p xmlns:a="http://schemas.openxmlformats.org/drawingml/2006/main">
             <a:pPr>
+              <a:buNone/>
               <a:defRPr sz="1500" b="0">
                 <a:solidFill>
                   <a:srgbClr val="8EB2C5"/>
@@ -11741,6 +11894,7 @@
           <a:lstStyle xmlns:a="http://schemas.openxmlformats.org/drawingml/2006/main"/>
           <a:p xmlns:a="http://schemas.openxmlformats.org/drawingml/2006/main">
             <a:pPr>
+              <a:buNone/>
               <a:defRPr sz="1350" b="1">
                 <a:solidFill>
                   <a:srgbClr val="FFBE3D"/>
@@ -11791,6 +11945,7 @@
           <a:lstStyle xmlns:a="http://schemas.openxmlformats.org/drawingml/2006/main"/>
           <a:p xmlns:a="http://schemas.openxmlformats.org/drawingml/2006/main">
             <a:pPr>
+              <a:buNone/>
               <a:defRPr sz="1950" b="1">
                 <a:solidFill>
                   <a:srgbClr val="F2FBFF"/>
@@ -11841,6 +11996,7 @@
           <a:lstStyle xmlns:a="http://schemas.openxmlformats.org/drawingml/2006/main"/>
           <a:p xmlns:a="http://schemas.openxmlformats.org/drawingml/2006/main">
             <a:pPr>
+              <a:buNone/>
               <a:defRPr sz="1500" b="0">
                 <a:solidFill>
                   <a:srgbClr val="8EB2C5"/>
@@ -11957,6 +12113,7 @@
           <a:lstStyle xmlns:a="http://schemas.openxmlformats.org/drawingml/2006/main"/>
           <a:p xmlns:a="http://schemas.openxmlformats.org/drawingml/2006/main">
             <a:pPr>
+              <a:buNone/>
               <a:defRPr sz="1050" b="1">
                 <a:solidFill>
                   <a:srgbClr val="58F28B"/>
@@ -12042,6 +12199,7 @@
           <a:lstStyle xmlns:a="http://schemas.openxmlformats.org/drawingml/2006/main"/>
           <a:p xmlns:a="http://schemas.openxmlformats.org/drawingml/2006/main">
             <a:pPr>
+              <a:buNone/>
               <a:defRPr sz="1050" b="1">
                 <a:solidFill>
                   <a:srgbClr val="A875FF"/>
@@ -12127,6 +12285,7 @@
           <a:lstStyle xmlns:a="http://schemas.openxmlformats.org/drawingml/2006/main"/>
           <a:p xmlns:a="http://schemas.openxmlformats.org/drawingml/2006/main">
             <a:pPr>
+              <a:buNone/>
               <a:defRPr sz="1050" b="1">
                 <a:solidFill>
                   <a:srgbClr val="FFBE3D"/>

</xml_diff>

<commit_message>
docs(submission): finalize judge materials and roadmap
</commit_message>
<xml_diff>
--- a/docs/submission/aeos-buidl-ctc-2026-fall.pptx
+++ b/docs/submission/aeos-buidl-ctc-2026-fall.pptx
@@ -2,22 +2,22 @@
 <file path=ppt/presentation.xml><?xml version="1.0" encoding="utf-8"?>
 <p:presentation xmlns:p="http://schemas.openxmlformats.org/presentationml/2006/main">
   <p:sldMasterIdLst>
-    <p:sldMasterId xmlns:r="http://schemas.openxmlformats.org/officeDocument/2006/relationships" id="2147483648" r:id="Rc19dec4bbc504d79"/>
+    <p:sldMasterId xmlns:r="http://schemas.openxmlformats.org/officeDocument/2006/relationships" id="2147483648" r:id="Rd5a62e02aea5480c"/>
   </p:sldMasterIdLst>
   <p:notesMasterIdLst>
-    <p:notesMasterId xmlns:r="http://schemas.openxmlformats.org/officeDocument/2006/relationships" r:id="R26438aa8a3f64160"/>
+    <p:notesMasterId xmlns:r="http://schemas.openxmlformats.org/officeDocument/2006/relationships" r:id="R15fa0f8ca28e4ea1"/>
   </p:notesMasterIdLst>
   <p:sldIdLst>
-    <p:sldId xmlns:r="http://schemas.openxmlformats.org/officeDocument/2006/relationships" id="256" r:id="Rd796ebe19e55411b"/>
-    <p:sldId xmlns:r="http://schemas.openxmlformats.org/officeDocument/2006/relationships" id="257" r:id="R9f84659d37ca429b"/>
-    <p:sldId xmlns:r="http://schemas.openxmlformats.org/officeDocument/2006/relationships" id="258" r:id="Rd08db438595e427f"/>
-    <p:sldId xmlns:r="http://schemas.openxmlformats.org/officeDocument/2006/relationships" id="259" r:id="R005eee4721804791"/>
-    <p:sldId xmlns:r="http://schemas.openxmlformats.org/officeDocument/2006/relationships" id="260" r:id="R9ea8b250027f49ed"/>
-    <p:sldId xmlns:r="http://schemas.openxmlformats.org/officeDocument/2006/relationships" id="261" r:id="Rb7ecf6dc55ea4d17"/>
-    <p:sldId xmlns:r="http://schemas.openxmlformats.org/officeDocument/2006/relationships" id="262" r:id="R234eec48bd6e4f5d"/>
-    <p:sldId xmlns:r="http://schemas.openxmlformats.org/officeDocument/2006/relationships" id="263" r:id="R142c6ec6c15d4bc2"/>
-    <p:sldId xmlns:r="http://schemas.openxmlformats.org/officeDocument/2006/relationships" id="264" r:id="Ra5ad1c53ad0c46c2"/>
-    <p:sldId xmlns:r="http://schemas.openxmlformats.org/officeDocument/2006/relationships" id="265" r:id="R258f05294cda4835"/>
+    <p:sldId xmlns:r="http://schemas.openxmlformats.org/officeDocument/2006/relationships" id="256" r:id="R3fcff10343d54991"/>
+    <p:sldId xmlns:r="http://schemas.openxmlformats.org/officeDocument/2006/relationships" id="257" r:id="R2a6aded906394dce"/>
+    <p:sldId xmlns:r="http://schemas.openxmlformats.org/officeDocument/2006/relationships" id="258" r:id="Rd9a140986a3e4cf7"/>
+    <p:sldId xmlns:r="http://schemas.openxmlformats.org/officeDocument/2006/relationships" id="259" r:id="R6a37f738d1884998"/>
+    <p:sldId xmlns:r="http://schemas.openxmlformats.org/officeDocument/2006/relationships" id="260" r:id="R18503c7aa7594344"/>
+    <p:sldId xmlns:r="http://schemas.openxmlformats.org/officeDocument/2006/relationships" id="261" r:id="Rc546c757cc6b4aaf"/>
+    <p:sldId xmlns:r="http://schemas.openxmlformats.org/officeDocument/2006/relationships" id="262" r:id="R0310c6baa75b483f"/>
+    <p:sldId xmlns:r="http://schemas.openxmlformats.org/officeDocument/2006/relationships" id="263" r:id="R8a95d35e120a4c2e"/>
+    <p:sldId xmlns:r="http://schemas.openxmlformats.org/officeDocument/2006/relationships" id="264" r:id="R1ea5110a25894621"/>
+    <p:sldId xmlns:r="http://schemas.openxmlformats.org/officeDocument/2006/relationships" id="265" r:id="R7dcf0a34b7114635"/>
   </p:sldIdLst>
   <p:sldSz cx="12192000" cy="6858000"/>
   <p:notesSz cx="6858000" cy="9144000"/>
@@ -1251,7 +1251,12 @@
           <a:lstStyle xmlns:a="http://schemas.openxmlformats.org/drawingml/2006/main"/>
           <a:p xmlns:a="http://schemas.openxmlformats.org/drawingml/2006/main">
             <a:r>
-              <a:t>Tests support engineering credibility; they are not a substitute for the live demo or production audit.</a:t>
+              <a:t>The adoption hypothesis targets DAO treasury operators, DeFi risk teams and on-chain funds. Each recurring Evidence request and governed workflow creates verifiable Creditcoin activity.</a:t>
+            </a:r>
+          </a:p>
+          <a:p xmlns:a="http://schemas.openxmlformats.org/drawingml/2006/main">
+            <a:r>
+              <a:t>No users, pilots or partnerships are claimed. A bounded call seeks two to three consented practitioner interviews; social engagement alone is not validation.</a:t>
             </a:r>
           </a:p>
           <a:p xmlns:a="http://schemas.openxmlformats.org/drawingml/2006/main">
@@ -1271,17 +1276,12 @@
           </a:p>
           <a:p xmlns:a="http://schemas.openxmlformats.org/drawingml/2006/main">
             <a:r>
-              <a:t>- C:/Users/P15v/CodeBuddy/AEOS/docs/submission/asc-integration-summary.md</a:t>
-            </a:r>
-          </a:p>
-          <a:p xmlns:a="http://schemas.openxmlformats.org/drawingml/2006/main">
-            <a:r>
-              <a:t>- https://dorahacks.io/hackathon/buidl-ctc-2026-fall/detail</a:t>
-            </a:r>
-          </a:p>
-          <a:p xmlns:a="http://schemas.openxmlformats.org/drawingml/2006/main">
-            <a:r>
-              <a:t>- https://docs.creditcoin.org/usc</a:t>
+              <a:t>- C:/Users/P15v/CodeBuddy/AEOS/docs/hackathon-competition-audit.md</a:t>
+            </a:r>
+          </a:p>
+          <a:p xmlns:a="http://schemas.openxmlformats.org/drawingml/2006/main">
+            <a:r>
+              <a:t>- https://buidl.creditcoin.org/</a:t>
             </a:r>
           </a:p>
         </p:txBody>
@@ -1449,7 +1449,7 @@
   </p:cSld>
   <p:clrMap bg1="lt1" tx1="dk1" bg2="lt2" tx2="dk2" accent1="accent1" accent2="accent2" accent3="accent3" accent4="accent4" accent5="accent5" accent6="accent6" hlink="hlink" folHlink="folHlink"/>
   <p:sldLayoutIdLst>
-    <p:sldLayoutId xmlns:r="http://schemas.openxmlformats.org/officeDocument/2006/relationships" id="2147483649" r:id="R07a904232df6482e"/>
+    <p:sldLayoutId xmlns:r="http://schemas.openxmlformats.org/officeDocument/2006/relationships" id="2147483649" r:id="Rce285164de204faf"/>
   </p:sldLayoutIdLst>
   <p:txStyles>
     <p:titleStyle>
@@ -10315,7 +10315,7 @@
                   <a:srgbClr val="13E6FF"/>
                 </a:solidFill>
               </a:rPr>
-              <a:t>ENGINEERING PROOF</a:t>
+              <a:t>ADOPTION PATH</a:t>
             </a:r>
           </a:p>
         </p:txBody>
@@ -10417,7 +10417,7 @@
                   <a:srgbClr val="F2FBFF"/>
                 </a:solidFill>
               </a:rPr>
-              <a:t>The safety boundary is tested at every layer</a:t>
+              <a:t>Verified DAO workflows create recurring Creditcoin usage</a:t>
             </a:r>
           </a:p>
         </p:txBody>
@@ -10550,7 +10550,7 @@
                   <a:srgbClr val="58F28B"/>
                 </a:solidFill>
               </a:rPr>
-              <a:t>459 / 459</a:t>
+              <a:t>DAO TEAMS</a:t>
             </a:r>
           </a:p>
         </p:txBody>
@@ -10601,7 +10601,7 @@
                   <a:srgbClr val="8EB2C5"/>
                 </a:solidFill>
               </a:rPr>
-              <a:t>API tests</a:t>
+              <a:t>Cross-chain facts</a:t>
             </a:r>
           </a:p>
         </p:txBody>
@@ -10652,7 +10652,7 @@
                   <a:srgbClr val="58F28B"/>
                 </a:solidFill>
               </a:rPr>
-              <a:t>23 / 23</a:t>
+              <a:t>RISK TEAMS</a:t>
             </a:r>
           </a:p>
         </p:txBody>
@@ -10703,7 +10703,7 @@
                   <a:srgbClr val="8EB2C5"/>
                 </a:solidFill>
               </a:rPr>
-              <a:t>Web tests</a:t>
+              <a:t>Cited challenges</a:t>
             </a:r>
           </a:p>
         </p:txBody>
@@ -10754,7 +10754,7 @@
                   <a:srgbClr val="A875FF"/>
                 </a:solidFill>
               </a:rPr>
-              <a:t>21 / 21</a:t>
+              <a:t>ONCHAIN FUNDS</a:t>
             </a:r>
           </a:p>
         </p:txBody>
@@ -10805,7 +10805,7 @@
                   <a:srgbClr val="8EB2C5"/>
                 </a:solidFill>
               </a:rPr>
-              <a:t>Agent eval</a:t>
+              <a:t>Governed actions</a:t>
             </a:r>
           </a:p>
         </p:txBody>
@@ -10856,7 +10856,7 @@
                   <a:srgbClr val="A875FF"/>
                 </a:solidFill>
               </a:rPr>
-              <a:t>5 / 5</a:t>
+              <a:t>PROOF JOBS</a:t>
             </a:r>
           </a:p>
         </p:txBody>
@@ -10907,7 +10907,7 @@
                   <a:srgbClr val="8EB2C5"/>
                 </a:solidFill>
               </a:rPr>
-              <a:t>RAG eval</a:t>
+              <a:t>Attestcoin demand</a:t>
             </a:r>
           </a:p>
         </p:txBody>
@@ -10958,7 +10958,7 @@
                   <a:srgbClr val="13E6FF"/>
                 </a:solidFill>
               </a:rPr>
-              <a:t>693</a:t>
+              <a:t>GOV TXS</a:t>
             </a:r>
           </a:p>
         </p:txBody>
@@ -11009,7 +11009,7 @@
                   <a:srgbClr val="8EB2C5"/>
                 </a:solidFill>
               </a:rPr>
-              <a:t>files secret-scanned</a:t>
+              <a:t>Creditcoin activity</a:t>
             </a:r>
           </a:p>
         </p:txBody>
@@ -11060,7 +11060,7 @@
                   <a:srgbClr val="58F28B"/>
                 </a:solidFill>
               </a:rPr>
-              <a:t>0</a:t>
+              <a:t>AUDIT TRAIL</a:t>
             </a:r>
           </a:p>
         </p:txBody>
@@ -11111,7 +11111,7 @@
                   <a:srgbClr val="8EB2C5"/>
                 </a:solidFill>
               </a:rPr>
-              <a:t>secret findings</a:t>
+              <a:t>Repeatable review</a:t>
             </a:r>
           </a:p>
         </p:txBody>
@@ -11193,7 +11193,7 @@
                   <a:srgbClr val="F2FBFF"/>
                 </a:solidFill>
               </a:rPr>
-              <a:t>Forgery→proof reject  ·  stale→fail closed  ·  replay→dedup  ·  cross-tenant→RLS  ·  AI→no signer</a:t>
+              <a:t>DISCOVERY OPEN  ·  2–3 PRACTITIONER INTERVIEWS TARGETED  ·  ZERO USERS OR PILOTS CLAIMED</a:t>
             </a:r>
           </a:p>
         </p:txBody>

</xml_diff>